<commit_message>
docs: refine final report deck
</commit_message>
<xml_diff>
--- a/docs/emotionbudget-final-report.pptx
+++ b/docs/emotionbudget-final-report.pptx
@@ -1593,7 +1593,7 @@
                 <a:ea typeface="Malgun Gothic"/>
                 <a:cs typeface="Malgun Gothic"/>
               </a:rPr>
-              <a:t>단순한 지출 기록을 넘어, 소비 당시의 감정과 금액을 함께 기록해 나의 소비 패턴을 분석하는 모바일 가계부 앱입니다.</a:t>
+              <a:t>감정과 금액을 함께 기록하고 소비 패턴을 분석합니다.</a:t>
             </a:r>
           </a:p>
         </p:txBody>
@@ -2565,7 +2565,7 @@
                 <a:ea typeface="Malgun Gothic"/>
                 <a:cs typeface="Malgun Gothic"/>
               </a:rPr>
-              <a:t>기획 &amp; 와이어프레임</a:t>
+              <a:t>기획·화면 설계</a:t>
             </a:r>
           </a:p>
         </p:txBody>
@@ -3081,7 +3081,7 @@
                 <a:ea typeface="Malgun Gothic"/>
                 <a:cs typeface="Malgun Gothic"/>
               </a:rPr>
-              <a:t>분석 화면 &amp; 발표</a:t>
+              <a:t>분석·발표</a:t>
             </a:r>
           </a:p>
         </p:txBody>
@@ -3145,7 +3145,7 @@
                 <a:ea typeface="Malgun Gothic"/>
                 <a:cs typeface="Malgun Gothic"/>
               </a:rPr>
-              <a:t>차트, 리포트, 시연 데이터 구성</a:t>
+              <a:t>차트, 리포트, 발표 화면 구성</a:t>
             </a:r>
           </a:p>
         </p:txBody>
@@ -3650,7 +3650,7 @@
                 <a:ea typeface="Malgun Gothic"/>
                 <a:cs typeface="Malgun Gothic"/>
               </a:rPr>
-              <a:t>제출 전 유튜브 로그아웃 상태에서 재생 여부 확인</a:t>
+              <a:t>3분 이내 프로젝트 소개 영상</a:t>
             </a:r>
           </a:p>
         </p:txBody>
@@ -4102,7 +4102,7 @@
                 <a:ea typeface="Malgun Gothic"/>
                 <a:cs typeface="Malgun Gothic"/>
               </a:rPr>
-              <a:t>검색어, 기간, 유형, 카테고리, 감정, 금액 범위로 결과 확인</a:t>
+              <a:t>검색어, 기간, 유형, 감정, 금액 범위로 결과 확인</a:t>
             </a:r>
           </a:p>
         </p:txBody>
@@ -4490,7 +4490,7 @@
                 <a:ea typeface="Malgun Gothic"/>
                 <a:cs typeface="Malgun Gothic"/>
               </a:rPr>
-              <a:t>감정별 금액·빈도 그래프와 감정 소비 진단 카드 제공</a:t>
+              <a:t>감정별 금액·빈도 그래프와 진단 카드 제공</a:t>
             </a:r>
           </a:p>
         </p:txBody>
@@ -4748,7 +4748,7 @@
                 <a:ea typeface="Malgun Gothic"/>
                 <a:cs typeface="Malgun Gothic"/>
               </a:rPr>
-              <a:t>샘플 데이터 구성</a:t>
+              <a:t>제출 영상 구성</a:t>
             </a:r>
           </a:p>
         </p:txBody>
@@ -4812,7 +4812,7 @@
                 <a:ea typeface="Malgun Gothic"/>
                 <a:cs typeface="Malgun Gothic"/>
               </a:rPr>
-              <a:t>2026년 4, 5, 6, 7월 데이터와 6월 주간별 기록으로 시연 가능</a:t>
+              <a:t>기록 입력, 검색 결과, 월별 통계, 감정 분석 흐름을 순서대로 시연</a:t>
             </a:r>
           </a:p>
         </p:txBody>

</xml_diff>